<commit_message>
fixed typos on cheat sheet
</commit_message>
<xml_diff>
--- a/cheat_sheet_DE.pptx
+++ b/cheat_sheet_DE.pptx
@@ -13835,7 +13835,7 @@
                   <a:schemeClr val="tx1"/>
                 </a:solidFill>
               </a:rPr>
-              <a:t>4</a:t>
+              <a:t>6</a:t>
             </a:r>
           </a:p>
         </p:txBody>
@@ -14336,7 +14336,7 @@
         <p:spPr>
           <a:xfrm>
             <a:off x="184024" y="846836"/>
-            <a:ext cx="1454244" cy="217432"/>
+            <a:ext cx="2297424" cy="217432"/>
           </a:xfrm>
           <a:prstGeom prst="rect">
             <a:avLst/>
@@ -14351,7 +14351,7 @@
           <a:p>
             <a:r>
               <a:rPr lang="de-DE" sz="813" b="1" dirty="0"/>
-              <a:t>Ungültige Werte markieren</a:t>
+              <a:t>Ungültige Werte markieren (nicht entfernen!)</a:t>
             </a:r>
           </a:p>
         </p:txBody>

</xml_diff>